<commit_message>
Segunda avaliação simulada: consistência entre contratos, código e docs
- OpenAPI v2: GET /v2/orders?updatedSince= (reconciliação, planejado para 60 dias)
- OpenAPI v1: remove token obrigatório, que contradizia o consumidor atual; ADR-007 explica
- EfOrderStore: só a violação da chave de idempotency_keys vira 409
- README: SQLite em arquivo temporário (não em memória) e badge do CI
- Remove os quadros "Para o avaliador" dos documentos
- Slides alinhados aos docs (custo, FTE, ameaças, residência, reconciliação)
- PDFs regenerados; fase 7 registrada em uso-de-ia.md
</commit_message>
<xml_diff>
--- a/entregaveis/apresentacao.pptx
+++ b/entregaveis/apresentacao.pptx
@@ -3832,7 +3832,7 @@
                           <a:ea typeface="Calibri" pitchFamily="34" charset="-122"/>
                           <a:cs typeface="Calibri" pitchFamily="34" charset="-120"/>
                         </a:rPr>
-                        <a:t>Catálogo em lote + cache, Pedidos stateless com autoescala, células</a:t>
+                        <a:t>Catálogo em lote + cache, Pedidos stateless com autoescala</a:t>
                       </a:r>
                       <a:endParaRPr lang="en-US" sz="1300" dirty="0">
                         <a:latin typeface="Calibri" charset="0"/>
@@ -4862,7 +4862,7 @@
                           <a:ea typeface="Calibri" pitchFamily="34" charset="-122"/>
                           <a:cs typeface="Calibri" pitchFamily="34" charset="-120"/>
                         </a:rPr>
-                        <a:t>OAuth2 com escopos, célula por país, eventos sem dado pessoal</a:t>
+                        <a:t>OAuth2 com escopos, coluna de país (célula só se a lei exigir), eventos sem dado pessoal</a:t>
                       </a:r>
                       <a:endParaRPr lang="en-US" sz="1300" dirty="0">
                         <a:latin typeface="Calibri" charset="0"/>
@@ -6007,6 +6007,10 @@
             <a:prstDash val="solid"/>
           </a:ln>
         </p:spPr>
+        <p:txBody>
+          <a:bodyPr/>
+          <a:p/>
+        </p:txBody>
       </p:sp>
       <p:sp>
         <p:nvSpPr>
@@ -6112,6 +6116,10 @@
             <a:prstDash val="solid"/>
           </a:ln>
         </p:spPr>
+        <p:txBody>
+          <a:bodyPr/>
+          <a:p/>
+        </p:txBody>
       </p:sp>
       <p:sp>
         <p:nvSpPr>
@@ -6217,6 +6225,10 @@
             <a:prstDash val="solid"/>
           </a:ln>
         </p:spPr>
+        <p:txBody>
+          <a:bodyPr/>
+          <a:p/>
+        </p:txBody>
       </p:sp>
       <p:sp>
         <p:nvSpPr>
@@ -6322,6 +6334,10 @@
             <a:prstDash val="solid"/>
           </a:ln>
         </p:spPr>
+        <p:txBody>
+          <a:bodyPr/>
+          <a:p/>
+        </p:txBody>
       </p:sp>
       <p:sp>
         <p:nvSpPr>
@@ -6395,7 +6411,7 @@
                 <a:ea typeface="Calibri" pitchFamily="34" charset="-122"/>
                 <a:cs typeface="Calibri" pitchFamily="34" charset="-120"/>
               </a:rPr>
-              <a:t>Parceiro pode consultar GET /v2/orders/{id}</a:t>
+              <a:t>Parceiro consulta GET /v2/orders/{id} ou GET /v2/orders?updatedSince=</a:t>
             </a:r>
             <a:endParaRPr lang="en-US" sz="1100" dirty="0"/>
           </a:p>
@@ -12539,7 +12555,7 @@
                           <a:ea typeface="Calibri" pitchFamily="34" charset="-122"/>
                           <a:cs typeface="Calibri" pitchFamily="34" charset="-120"/>
                         </a:rPr>
-                        <a:t>60 dias</a:t>
+                        <a:t>Provado na fatia</a:t>
                       </a:r>
                       <a:endParaRPr lang="en-US" sz="1300" dirty="0">
                         <a:latin typeface="Calibri" charset="0"/>
@@ -13293,7 +13309,7 @@
                           <a:ea typeface="Calibri" pitchFamily="34" charset="-122"/>
                           <a:cs typeface="Calibri" pitchFamily="34" charset="-120"/>
                         </a:rPr>
-                        <a:t>Célula por país; eventos e logs só com IDs</a:t>
+                        <a:t>Coluna de país (célula se a lei exigir); eventos e logs só com IDs</a:t>
                       </a:r>
                       <a:endParaRPr lang="en-US" sz="1300" dirty="0">
                         <a:latin typeface="Calibri" charset="0"/>
@@ -13998,7 +14014,7 @@
                 <a:ea typeface="Calibri" pitchFamily="34" charset="-122"/>
                 <a:cs typeface="Calibri" pitchFamily="34" charset="-120"/>
               </a:rPr>
-              <a:t>19 ameaças mapeadas em docs/05-threat-model.md. LGPD: exclusão por pseudonimização, mantendo o registro fiscal.</a:t>
+              <a:t>25 ameaças mapeadas em docs/05-threat-model.md (inclui IA). LGPD: exclusão por pseudonimização, mantendo o registro fiscal.</a:t>
             </a:r>
             <a:endParaRPr lang="en-US" sz="1200" dirty="0"/>
           </a:p>
@@ -18811,7 +18827,7 @@
                           <a:ea typeface="Calibri" pitchFamily="34" charset="-122"/>
                           <a:cs typeface="Calibri" pitchFamily="34" charset="-120"/>
                         </a:rPr>
-                        <a:t>Célula por país</a:t>
+                        <a:t>Coluna de país; célula mínima só se a lei exigir</a:t>
                       </a:r>
                       <a:endParaRPr lang="en-US" sz="1500" dirty="0">
                         <a:latin typeface="Calibri" charset="0"/>
@@ -18879,7 +18895,7 @@
                           <a:ea typeface="Calibri" pitchFamily="34" charset="-122"/>
                           <a:cs typeface="Calibri" pitchFamily="34" charset="-120"/>
                         </a:rPr>
-                        <a:t>Residência sem trocar de banco</a:t>
+                        <a:t>Residência sem gastar antes do parecer jurídico</a:t>
                       </a:r>
                       <a:endParaRPr lang="en-US" sz="1500" dirty="0">
                         <a:latin typeface="Calibri" charset="0"/>
@@ -18947,7 +18963,7 @@
                           <a:ea typeface="Calibri" pitchFamily="34" charset="-122"/>
                           <a:cs typeface="Calibri" pitchFamily="34" charset="-120"/>
                         </a:rPr>
-                        <a:t>+60% a 80% de infraestrutura</a:t>
+                        <a:t>Escolha final depende do jurídico até o dia 30</a:t>
                       </a:r>
                       <a:endParaRPr lang="en-US" sz="1500" dirty="0">
                         <a:latin typeface="Calibri" charset="0"/>
@@ -20591,7 +20607,7 @@
                 <a:ea typeface="Calibri" pitchFamily="34" charset="-122"/>
                 <a:cs typeface="Calibri" pitchFamily="34" charset="-120"/>
               </a:rPr>
-              <a:t>~R$ 155 mil</a:t>
+              <a:t>~R$ 93 mil</a:t>
             </a:r>
             <a:endParaRPr lang="en-US" sz="3600" dirty="0"/>
           </a:p>
@@ -20630,7 +20646,7 @@
                 <a:ea typeface="Calibri" pitchFamily="34" charset="-122"/>
                 <a:cs typeface="Calibri" pitchFamily="34" charset="-120"/>
               </a:rPr>
-              <a:t>custo estimado da fase 1</a:t>
+              <a:t>custo da fase 1 sem IA (~R$ 79 mil com IA)</a:t>
             </a:r>
             <a:endParaRPr lang="en-US" sz="1300" dirty="0"/>
           </a:p>
@@ -20669,7 +20685,7 @@
                 <a:ea typeface="Calibri" pitchFamily="34" charset="-122"/>
                 <a:cs typeface="Calibri" pitchFamily="34" charset="-120"/>
               </a:rPr>
-              <a:t>~5,5 FTE</a:t>
+              <a:t>~5,25 FTE</a:t>
             </a:r>
             <a:endParaRPr lang="en-US" sz="3600" dirty="0"/>
           </a:p>
@@ -20740,6 +20756,10 @@
             <a:prstDash val="solid"/>
           </a:ln>
         </p:spPr>
+        <p:txBody>
+          <a:bodyPr/>
+          <a:p/>
+        </p:txBody>
       </p:sp>
       <p:sp>
         <p:nvSpPr>
@@ -20912,6 +20932,10 @@
             <a:prstDash val="solid"/>
           </a:ln>
         </p:spPr>
+        <p:txBody>
+          <a:bodyPr/>
+          <a:p/>
+        </p:txBody>
       </p:sp>
       <p:sp>
         <p:nvSpPr>
@@ -21094,7 +21118,7 @@
                 <a:ea typeface="Calibri" pitchFamily="34" charset="-122"/>
                 <a:cs typeface="Calibri" pitchFamily="34" charset="-120"/>
               </a:rPr>
-              <a:t>Time e taxa da estimativa</a:t>
+              <a:t>Salário de SRE, tributos e margem</a:t>
             </a:r>
             <a:endParaRPr lang="en-US" sz="1300" dirty="0"/>
           </a:p>

</xml_diff>